<commit_message>
Dogfood samples, one-command launcher, PROJECT.md, and doc corrections
- examples/dogfood/: a full set of documents docloom generated from its own
  PROJECT.md (a deck, a 95-block whitepaper in 4 formats, an infographic, a
  workbook, and two architecture diagrams), plus a self-contained render script.
  This is the real output the system produces; the root README points to it.
- PROJECT.md: an accurate, fact-checked project explainer suitable as a source.
- studio.ps1 / studio.cmd / studio.sh: one-command bring-up (deps + web build +
  server on one port), with a resvg self-heal so exports can't silently blank.
  .gitattributes pins the launchers' line endings.
- Docs: corrected the D2-vs-Diagram-IR split description, the [pdf,diagrams]
  extra, podcast/artifact-kind counts, and removed stale internal process docs.
</commit_message>
<xml_diff>
--- a/examples/output/showcase.pptx
+++ b/examples/output/showcase.pptx
@@ -204,6 +204,7 @@
                   <a:solidFill>
                     <a:srgbClr val="0F172A"/>
                   </a:solidFill>
+                  <a:latin typeface="Sora"/>
                 </a:defRPr>
               </a:pPr>
             </a:p>
@@ -244,7 +245,7 @@
                 <a:solidFill>
                   <a:srgbClr val="64748B"/>
                 </a:solidFill>
-                <a:latin typeface="Inter"/>
+                <a:latin typeface="Sora"/>
               </a:defRPr>
             </a:pPr>
           </a:p>
@@ -287,7 +288,7 @@
                 <a:solidFill>
                   <a:srgbClr val="64748B"/>
                 </a:solidFill>
-                <a:latin typeface="Inter"/>
+                <a:latin typeface="Sora"/>
               </a:defRPr>
             </a:pPr>
           </a:p>
@@ -414,6 +415,7 @@
                   <a:solidFill>
                     <a:srgbClr val="0F172A"/>
                   </a:solidFill>
+                  <a:latin typeface="Sora"/>
                 </a:defRPr>
               </a:pPr>
             </a:p>
@@ -454,7 +456,7 @@
                 <a:solidFill>
                   <a:srgbClr val="64748B"/>
                 </a:solidFill>
-                <a:latin typeface="Inter"/>
+                <a:latin typeface="Sora"/>
               </a:defRPr>
             </a:pPr>
           </a:p>
@@ -497,7 +499,7 @@
                 <a:solidFill>
                   <a:srgbClr val="64748B"/>
                 </a:solidFill>
-                <a:latin typeface="Inter"/>
+                <a:latin typeface="Sora"/>
               </a:defRPr>
             </a:pPr>
           </a:p>
@@ -3781,8 +3783,8 @@
         </p:nvSpPr>
         <p:spPr>
           <a:xfrm>
-            <a:off x="548640" y="2360600"/>
-            <a:ext cx="11094415" cy="2481977"/>
+            <a:off x="548640" y="2596263"/>
+            <a:ext cx="11094415" cy="1920874"/>
           </a:xfrm>
           <a:prstGeom prst="rect">
             <a:avLst/>
@@ -3801,7 +3803,7 @@
               </a:spcAft>
             </a:pPr>
             <a:r>
-              <a:rPr sz="2261">
+              <a:rPr sz="1750">
                 <a:solidFill>
                   <a:srgbClr val="4F46E5"/>
                 </a:solidFill>
@@ -3810,7 +3812,7 @@
               <a:t>1. </a:t>
             </a:r>
             <a:r>
-              <a:rPr sz="2261" b="0" i="0">
+              <a:rPr sz="1750" b="0" i="0">
                 <a:solidFill>
                   <a:srgbClr val="0F172A"/>
                 </a:solidFill>
@@ -3826,7 +3828,7 @@
               </a:spcAft>
             </a:pPr>
             <a:r>
-              <a:rPr sz="2261">
+              <a:rPr sz="1750">
                 <a:solidFill>
                   <a:srgbClr val="4F46E5"/>
                 </a:solidFill>
@@ -3835,7 +3837,7 @@
               <a:t>2. </a:t>
             </a:r>
             <a:r>
-              <a:rPr sz="2261" b="0" i="0">
+              <a:rPr sz="1750" b="0" i="0">
                 <a:solidFill>
                   <a:srgbClr val="0F172A"/>
                 </a:solidFill>
@@ -3851,7 +3853,7 @@
               </a:spcAft>
             </a:pPr>
             <a:r>
-              <a:rPr sz="2261">
+              <a:rPr sz="1750">
                 <a:solidFill>
                   <a:srgbClr val="4F46E5"/>
                 </a:solidFill>
@@ -3860,7 +3862,7 @@
               <a:t>3. </a:t>
             </a:r>
             <a:r>
-              <a:rPr sz="2261" b="0" i="0">
+              <a:rPr sz="1750" b="0" i="0">
                 <a:solidFill>
                   <a:srgbClr val="0F172A"/>
                 </a:solidFill>
@@ -3876,7 +3878,7 @@
               </a:spcAft>
             </a:pPr>
             <a:r>
-              <a:rPr sz="2261">
+              <a:rPr sz="1750">
                 <a:solidFill>
                   <a:srgbClr val="4F46E5"/>
                 </a:solidFill>
@@ -3885,7 +3887,7 @@
               <a:t>4. </a:t>
             </a:r>
             <a:r>
-              <a:rPr sz="2261" b="0" i="0">
+              <a:rPr sz="1750" b="0" i="0">
                 <a:solidFill>
                   <a:srgbClr val="0F172A"/>
                 </a:solidFill>
@@ -3901,7 +3903,7 @@
               </a:spcAft>
             </a:pPr>
             <a:r>
-              <a:rPr sz="2261">
+              <a:rPr sz="1750">
                 <a:solidFill>
                   <a:srgbClr val="4F46E5"/>
                 </a:solidFill>
@@ -3910,7 +3912,7 @@
               <a:t>5. </a:t>
             </a:r>
             <a:r>
-              <a:rPr sz="2261" b="0" i="0">
+              <a:rPr sz="1750" b="0" i="0">
                 <a:solidFill>
                   <a:srgbClr val="0F172A"/>
                 </a:solidFill>
@@ -4033,8 +4035,8 @@
         </p:nvSpPr>
         <p:spPr>
           <a:xfrm>
-            <a:off x="548640" y="2127878"/>
-            <a:ext cx="11094415" cy="1853027"/>
+            <a:off x="548640" y="2283931"/>
+            <a:ext cx="11094415" cy="1536699"/>
           </a:xfrm>
           <a:prstGeom prst="rect">
             <a:avLst/>
@@ -4053,7 +4055,7 @@
               </a:spcAft>
             </a:pPr>
             <a:r>
-              <a:rPr sz="2110">
+              <a:rPr sz="1750">
                 <a:solidFill>
                   <a:srgbClr val="4F46E5"/>
                 </a:solidFill>
@@ -4062,7 +4064,7 @@
               <a:t>•  </a:t>
             </a:r>
             <a:r>
-              <a:rPr sz="2110" b="0" i="0">
+              <a:rPr sz="1750" b="0" i="0">
                 <a:solidFill>
                   <a:srgbClr val="0F172A"/>
                 </a:solidFill>
@@ -4078,7 +4080,7 @@
               </a:spcAft>
             </a:pPr>
             <a:r>
-              <a:rPr sz="2110">
+              <a:rPr sz="1750">
                 <a:solidFill>
                   <a:srgbClr val="4F46E5"/>
                 </a:solidFill>
@@ -4087,7 +4089,7 @@
               <a:t>•  </a:t>
             </a:r>
             <a:r>
-              <a:rPr sz="2110" b="0" i="0">
+              <a:rPr sz="1750" b="0" i="0">
                 <a:solidFill>
                   <a:srgbClr val="0F172A"/>
                 </a:solidFill>
@@ -4103,7 +4105,7 @@
               </a:spcAft>
             </a:pPr>
             <a:r>
-              <a:rPr sz="2110">
+              <a:rPr sz="1750">
                 <a:solidFill>
                   <a:srgbClr val="4F46E5"/>
                 </a:solidFill>
@@ -4112,7 +4114,7 @@
               <a:t>•  </a:t>
             </a:r>
             <a:r>
-              <a:rPr sz="2110" b="0" i="0">
+              <a:rPr sz="1750" b="0" i="0">
                 <a:solidFill>
                   <a:srgbClr val="0F172A"/>
                 </a:solidFill>
@@ -4128,7 +4130,7 @@
               </a:spcAft>
             </a:pPr>
             <a:r>
-              <a:rPr sz="2110">
+              <a:rPr sz="1750">
                 <a:solidFill>
                   <a:srgbClr val="4F46E5"/>
                 </a:solidFill>
@@ -4137,7 +4139,7 @@
               <a:t>•  </a:t>
             </a:r>
             <a:r>
-              <a:rPr sz="2110" b="0" i="0">
+              <a:rPr sz="1750" b="0" i="0">
                 <a:solidFill>
                   <a:srgbClr val="0F172A"/>
                 </a:solidFill>
@@ -4156,14 +4158,14 @@
         </p:nvSpPr>
         <p:spPr>
           <a:xfrm>
-            <a:off x="548640" y="4584409"/>
-            <a:ext cx="11094415" cy="579546"/>
+            <a:off x="548640" y="4424135"/>
+            <a:ext cx="11094415" cy="524319"/>
           </a:xfrm>
           <a:prstGeom prst="rect">
             <a:avLst/>
           </a:prstGeom>
           <a:solidFill>
-            <a:srgbClr val="F4F6FB"/>
+            <a:srgbClr val="F0E9DD"/>
           </a:solidFill>
           <a:ln>
             <a:noFill/>
@@ -4200,14 +4202,14 @@
         </p:nvSpPr>
         <p:spPr>
           <a:xfrm>
-            <a:off x="548640" y="4584409"/>
-            <a:ext cx="73152" cy="579546"/>
+            <a:off x="548640" y="4424135"/>
+            <a:ext cx="73152" cy="524319"/>
           </a:xfrm>
           <a:prstGeom prst="rect">
             <a:avLst/>
           </a:prstGeom>
           <a:solidFill>
-            <a:srgbClr val="64748B"/>
+            <a:srgbClr val="94630D"/>
           </a:solidFill>
           <a:ln>
             <a:noFill/>
@@ -4244,8 +4246,8 @@
         </p:nvSpPr>
         <p:spPr>
           <a:xfrm>
-            <a:off x="749808" y="4712425"/>
-            <a:ext cx="10765231" cy="323514"/>
+            <a:off x="749808" y="4552151"/>
+            <a:ext cx="10765231" cy="268287"/>
           </a:xfrm>
           <a:prstGeom prst="rect">
             <a:avLst/>
@@ -4259,7 +4261,7 @@
           <a:lstStyle/>
           <a:p>
             <a:r>
-              <a:rPr sz="1959" b="0" i="0">
+              <a:rPr sz="1625" b="0" i="0">
                 <a:solidFill>
                   <a:srgbClr val="0F172A"/>
                 </a:solidFill>
@@ -4520,8 +4522,8 @@
         </p:nvSpPr>
         <p:spPr>
           <a:xfrm>
-            <a:off x="548640" y="2744708"/>
-            <a:ext cx="11094415" cy="1567434"/>
+            <a:off x="548640" y="2918970"/>
+            <a:ext cx="11094415" cy="1152524"/>
           </a:xfrm>
           <a:prstGeom prst="rect">
             <a:avLst/>
@@ -4540,7 +4542,7 @@
               </a:spcAft>
             </a:pPr>
             <a:r>
-              <a:rPr sz="2380">
+              <a:rPr sz="1750">
                 <a:solidFill>
                   <a:srgbClr val="4F46E5"/>
                 </a:solidFill>
@@ -4549,7 +4551,7 @@
               <a:t>•  </a:t>
             </a:r>
             <a:r>
-              <a:rPr sz="2380" b="0" i="0">
+              <a:rPr sz="1750" b="0" i="0">
                 <a:solidFill>
                   <a:srgbClr val="0F172A"/>
                 </a:solidFill>
@@ -4565,7 +4567,7 @@
               </a:spcAft>
             </a:pPr>
             <a:r>
-              <a:rPr sz="2380">
+              <a:rPr sz="1750">
                 <a:solidFill>
                   <a:srgbClr val="4F46E5"/>
                 </a:solidFill>
@@ -4574,7 +4576,7 @@
               <a:t>•  </a:t>
             </a:r>
             <a:r>
-              <a:rPr sz="2380" b="0" i="0">
+              <a:rPr sz="1750" b="0" i="0">
                 <a:solidFill>
                   <a:srgbClr val="0F172A"/>
                 </a:solidFill>
@@ -4590,7 +4592,7 @@
               </a:spcAft>
             </a:pPr>
             <a:r>
-              <a:rPr sz="2380">
+              <a:rPr sz="1750">
                 <a:solidFill>
                   <a:srgbClr val="4F46E5"/>
                 </a:solidFill>
@@ -4599,7 +4601,7 @@
               <a:t>•  </a:t>
             </a:r>
             <a:r>
-              <a:rPr sz="2380" b="0" i="0">
+              <a:rPr sz="1750" b="0" i="0">
                 <a:solidFill>
                   <a:srgbClr val="0F172A"/>
                 </a:solidFill>
@@ -4736,13 +4738,13 @@
           </a:bodyPr>
           <a:lstStyle/>
           <a:p>
-            <a:pPr>
+            <a:pPr marL="310896" indent="-310896">
               <a:spcAft>
                 <a:spcPts val="600"/>
               </a:spcAft>
             </a:pPr>
             <a:r>
-              <a:rPr sz="1200" b="0" i="0">
+              <a:rPr sz="1300" b="0" i="0">
                 <a:solidFill>
                   <a:srgbClr val="64748B"/>
                 </a:solidFill>
@@ -4752,13 +4754,13 @@
             </a:r>
           </a:p>
           <a:p>
-            <a:pPr>
+            <a:pPr marL="310896" indent="-310896">
               <a:spcAft>
                 <a:spcPts val="600"/>
               </a:spcAft>
             </a:pPr>
             <a:r>
-              <a:rPr sz="1200" b="0" i="0">
+              <a:rPr sz="1300" b="0" i="0">
                 <a:solidFill>
                   <a:srgbClr val="64748B"/>
                 </a:solidFill>
@@ -4985,8 +4987,8 @@
         </p:nvSpPr>
         <p:spPr>
           <a:xfrm>
-            <a:off x="548640" y="2525268"/>
-            <a:ext cx="11094415" cy="2089912"/>
+            <a:off x="548640" y="2757617"/>
+            <a:ext cx="11094415" cy="1536699"/>
           </a:xfrm>
           <a:prstGeom prst="rect">
             <a:avLst/>
@@ -5005,7 +5007,7 @@
               </a:spcAft>
             </a:pPr>
             <a:r>
-              <a:rPr sz="2380">
+              <a:rPr sz="1750">
                 <a:solidFill>
                   <a:srgbClr val="4F46E5"/>
                 </a:solidFill>
@@ -5014,7 +5016,7 @@
               <a:t>•  </a:t>
             </a:r>
             <a:r>
-              <a:rPr sz="2380" b="0" i="0">
+              <a:rPr sz="1750" b="0" i="0">
                 <a:solidFill>
                   <a:srgbClr val="0F172A"/>
                 </a:solidFill>
@@ -5030,7 +5032,7 @@
               </a:spcAft>
             </a:pPr>
             <a:r>
-              <a:rPr sz="2380">
+              <a:rPr sz="1750">
                 <a:solidFill>
                   <a:srgbClr val="4F46E5"/>
                 </a:solidFill>
@@ -5039,7 +5041,7 @@
               <a:t>•  </a:t>
             </a:r>
             <a:r>
-              <a:rPr sz="2380" b="0" i="0">
+              <a:rPr sz="1750" b="0" i="0">
                 <a:solidFill>
                   <a:srgbClr val="0F172A"/>
                 </a:solidFill>
@@ -5055,7 +5057,7 @@
               </a:spcAft>
             </a:pPr>
             <a:r>
-              <a:rPr sz="2380">
+              <a:rPr sz="1750">
                 <a:solidFill>
                   <a:srgbClr val="4F46E5"/>
                 </a:solidFill>
@@ -5064,7 +5066,7 @@
               <a:t>•  </a:t>
             </a:r>
             <a:r>
-              <a:rPr sz="2380" b="0" i="0">
+              <a:rPr sz="1750" b="0" i="0">
                 <a:solidFill>
                   <a:srgbClr val="0F172A"/>
                 </a:solidFill>
@@ -5080,7 +5082,7 @@
               </a:spcAft>
             </a:pPr>
             <a:r>
-              <a:rPr sz="2380">
+              <a:rPr sz="1750">
                 <a:solidFill>
                   <a:srgbClr val="4F46E5"/>
                 </a:solidFill>
@@ -5089,7 +5091,7 @@
               <a:t>•  </a:t>
             </a:r>
             <a:r>
-              <a:rPr sz="2380" b="0" i="0">
+              <a:rPr sz="1750" b="0" i="0">
                 <a:solidFill>
                   <a:srgbClr val="0F172A"/>
                 </a:solidFill>
@@ -5291,7 +5293,7 @@
         <p:spPr>
           <a:xfrm>
             <a:off x="713232" y="3487155"/>
-            <a:ext cx="2272969" cy="201168"/>
+            <a:ext cx="2272969" cy="237744"/>
           </a:xfrm>
           <a:prstGeom prst="rect">
             <a:avLst/>
@@ -5305,7 +5307,7 @@
           <a:lstStyle/>
           <a:p>
             <a:r>
-              <a:rPr sz="1100" b="0" i="0">
+              <a:rPr sz="1300" b="0" i="0">
                 <a:solidFill>
                   <a:srgbClr val="64748B"/>
                 </a:solidFill>
@@ -5324,8 +5326,8 @@
         </p:nvSpPr>
         <p:spPr>
           <a:xfrm>
-            <a:off x="713232" y="3743187"/>
-            <a:ext cx="2272969" cy="182880"/>
+            <a:off x="713232" y="3779763"/>
+            <a:ext cx="2272969" cy="201168"/>
           </a:xfrm>
           <a:prstGeom prst="rect">
             <a:avLst/>
@@ -5339,7 +5341,7 @@
           <a:lstStyle/>
           <a:p>
             <a:r>
-              <a:rPr sz="1000" b="0" i="0">
+              <a:rPr sz="1200" b="0" i="0">
                 <a:solidFill>
                   <a:srgbClr val="0D9488"/>
                 </a:solidFill>
@@ -5437,7 +5439,7 @@
         <p:spPr>
           <a:xfrm>
             <a:off x="3543985" y="3487155"/>
-            <a:ext cx="2272969" cy="201168"/>
+            <a:ext cx="2272969" cy="237744"/>
           </a:xfrm>
           <a:prstGeom prst="rect">
             <a:avLst/>
@@ -5451,7 +5453,7 @@
           <a:lstStyle/>
           <a:p>
             <a:r>
-              <a:rPr sz="1100" b="0" i="0">
+              <a:rPr sz="1300" b="0" i="0">
                 <a:solidFill>
                   <a:srgbClr val="64748B"/>
                 </a:solidFill>
@@ -5470,8 +5472,8 @@
         </p:nvSpPr>
         <p:spPr>
           <a:xfrm>
-            <a:off x="3543985" y="3743187"/>
-            <a:ext cx="2272969" cy="182880"/>
+            <a:off x="3543985" y="3779763"/>
+            <a:ext cx="2272969" cy="201168"/>
           </a:xfrm>
           <a:prstGeom prst="rect">
             <a:avLst/>
@@ -5485,7 +5487,7 @@
           <a:lstStyle/>
           <a:p>
             <a:r>
-              <a:rPr sz="1000" b="0" i="0">
+              <a:rPr sz="1200" b="0" i="0">
                 <a:solidFill>
                   <a:srgbClr val="0D9488"/>
                 </a:solidFill>
@@ -5583,7 +5585,7 @@
         <p:spPr>
           <a:xfrm>
             <a:off x="6374739" y="3487155"/>
-            <a:ext cx="2272969" cy="201168"/>
+            <a:ext cx="2272969" cy="237744"/>
           </a:xfrm>
           <a:prstGeom prst="rect">
             <a:avLst/>
@@ -5597,7 +5599,7 @@
           <a:lstStyle/>
           <a:p>
             <a:r>
-              <a:rPr sz="1100" b="0" i="0">
+              <a:rPr sz="1300" b="0" i="0">
                 <a:solidFill>
                   <a:srgbClr val="64748B"/>
                 </a:solidFill>
@@ -5616,8 +5618,8 @@
         </p:nvSpPr>
         <p:spPr>
           <a:xfrm>
-            <a:off x="6374739" y="3743187"/>
-            <a:ext cx="2272969" cy="182880"/>
+            <a:off x="6374739" y="3779763"/>
+            <a:ext cx="2272969" cy="201168"/>
           </a:xfrm>
           <a:prstGeom prst="rect">
             <a:avLst/>
@@ -5631,7 +5633,7 @@
           <a:lstStyle/>
           <a:p>
             <a:r>
-              <a:rPr sz="1000" b="0" i="0">
+              <a:rPr sz="1200" b="0" i="0">
                 <a:solidFill>
                   <a:srgbClr val="0D9488"/>
                 </a:solidFill>
@@ -5729,7 +5731,7 @@
         <p:spPr>
           <a:xfrm>
             <a:off x="9205493" y="3487155"/>
-            <a:ext cx="2272969" cy="201168"/>
+            <a:ext cx="2272969" cy="237744"/>
           </a:xfrm>
           <a:prstGeom prst="rect">
             <a:avLst/>
@@ -5743,7 +5745,7 @@
           <a:lstStyle/>
           <a:p>
             <a:r>
-              <a:rPr sz="1100" b="0" i="0">
+              <a:rPr sz="1300" b="0" i="0">
                 <a:solidFill>
                   <a:srgbClr val="64748B"/>
                 </a:solidFill>
@@ -5860,15 +5862,15 @@
       </p:sp>
       <p:graphicFrame>
         <p:nvGraphicFramePr>
-          <p:cNvPr id="4" name="Chart 3"/>
+          <p:cNvPr id="4" name="Chart 3" descr="Uninterrupted focus blocks per engineer per day" title="Uninterrupted focus blocks per engineer per day"/>
           <p:cNvGraphicFramePr>
             <a:graphicFrameLocks noGrp="1"/>
           </p:cNvGraphicFramePr>
           <p:nvPr/>
         </p:nvGraphicFramePr>
         <p:xfrm>
-          <a:off x="548640" y="1674815"/>
-          <a:ext cx="11094415" cy="4114800"/>
+          <a:off x="548640" y="1298448"/>
+          <a:ext cx="11094415" cy="5010912"/>
         </p:xfrm>
         <a:graphic>
           <a:graphicData uri="http://schemas.openxmlformats.org/drawingml/2006/chart">
@@ -5982,15 +5984,15 @@
       </p:sp>
       <p:graphicFrame>
         <p:nvGraphicFramePr>
-          <p:cNvPr id="4" name="Chart 3"/>
+          <p:cNvPr id="4" name="Chart 3" descr="Median across surveyed distributed engineering orgs." title="Sync meeting share of collaboration time"/>
           <p:cNvGraphicFramePr>
             <a:graphicFrameLocks noGrp="1"/>
           </p:cNvGraphicFramePr>
           <p:nvPr/>
         </p:nvGraphicFramePr>
         <p:xfrm>
-          <a:off x="548640" y="1574962"/>
-          <a:ext cx="11094415" cy="4114800"/>
+          <a:off x="548640" y="1398300"/>
+          <a:ext cx="11094415" cy="4673315"/>
         </p:xfrm>
         <a:graphic>
           <a:graphicData uri="http://schemas.openxmlformats.org/drawingml/2006/chart">
@@ -6006,7 +6008,7 @@
         </p:nvSpPr>
         <p:spPr>
           <a:xfrm>
-            <a:off x="548640" y="5726338"/>
+            <a:off x="548640" y="6108192"/>
             <a:ext cx="11094415" cy="201168"/>
           </a:xfrm>
           <a:prstGeom prst="rect">
@@ -6242,15 +6244,15 @@
       </p:sp>
       <p:graphicFrame>
         <p:nvGraphicFramePr>
-          <p:cNvPr id="4" name="Table 3"/>
+          <p:cNvPr id="4" name="Table 3" descr="Outcomes by async maturity quartile." title="Table"/>
           <p:cNvGraphicFramePr>
             <a:graphicFrameLocks noGrp="1"/>
           </p:cNvGraphicFramePr>
           <p:nvPr/>
         </p:nvGraphicFramePr>
         <p:xfrm>
-          <a:off x="548640" y="2878165"/>
-          <a:ext cx="6858000" cy="1011936"/>
+          <a:off x="2666847" y="2878165"/>
+          <a:ext cx="6857999" cy="1011936"/>
         </p:xfrm>
         <a:graphic>
           <a:graphicData uri="http://schemas.openxmlformats.org/drawingml/2006/table">
@@ -6259,9 +6261,9 @@
                 <a:tableStyleId>{5C22544A-7EE6-4342-B048-85BDC9FD1C3A}</a:tableStyleId>
               </a:tblPr>
               <a:tblGrid>
-                <a:gridCol w="2286000"/>
-                <a:gridCol w="2286000"/>
-                <a:gridCol w="2286000"/>
+                <a:gridCol w="1978269"/>
+                <a:gridCol w="2505807"/>
+                <a:gridCol w="2373923"/>
               </a:tblGrid>
               <a:tr h="252984">
                 <a:tc>
@@ -6274,7 +6276,7 @@
                           <a:solidFill>
                             <a:srgbClr val="FFFFFF"/>
                           </a:solidFill>
-                          <a:latin typeface="Inter"/>
+                          <a:latin typeface="Sora"/>
                         </a:rPr>
                         <a:t>Async maturity</a:t>
                       </a:r>
@@ -6296,7 +6298,7 @@
                           <a:solidFill>
                             <a:srgbClr val="FFFFFF"/>
                           </a:solidFill>
-                          <a:latin typeface="Inter"/>
+                          <a:latin typeface="Sora"/>
                         </a:rPr>
                         <a:t>Voluntary attrition</a:t>
                       </a:r>
@@ -6318,7 +6320,7 @@
                           <a:solidFill>
                             <a:srgbClr val="FFFFFF"/>
                           </a:solidFill>
-                          <a:latin typeface="Inter"/>
+                          <a:latin typeface="Sora"/>
                         </a:rPr>
                         <a:t>Focus blocks / day</a:t>
                       </a:r>
@@ -6342,7 +6344,7 @@
                           <a:solidFill>
                             <a:srgbClr val="0F172A"/>
                           </a:solidFill>
-                          <a:latin typeface="Inter"/>
+                          <a:latin typeface="Sora"/>
                         </a:rPr>
                         <a:t>Top quartile</a:t>
                       </a:r>
@@ -6364,7 +6366,7 @@
                           <a:solidFill>
                             <a:srgbClr val="0F172A"/>
                           </a:solidFill>
-                          <a:latin typeface="Inter"/>
+                          <a:latin typeface="Sora"/>
                         </a:rPr>
                         <a:t>9%</a:t>
                       </a:r>
@@ -6386,7 +6388,7 @@
                           <a:solidFill>
                             <a:srgbClr val="0F172A"/>
                           </a:solidFill>
-                          <a:latin typeface="Inter"/>
+                          <a:latin typeface="Sora"/>
                         </a:rPr>
                         <a:t>3.2</a:t>
                       </a:r>
@@ -6410,7 +6412,7 @@
                           <a:solidFill>
                             <a:srgbClr val="0F172A"/>
                           </a:solidFill>
-                          <a:latin typeface="Inter"/>
+                          <a:latin typeface="Sora"/>
                         </a:rPr>
                         <a:t>Median</a:t>
                       </a:r>
@@ -6432,7 +6434,7 @@
                           <a:solidFill>
                             <a:srgbClr val="0F172A"/>
                           </a:solidFill>
-                          <a:latin typeface="Inter"/>
+                          <a:latin typeface="Sora"/>
                         </a:rPr>
                         <a:t>13%</a:t>
                       </a:r>
@@ -6454,7 +6456,7 @@
                           <a:solidFill>
                             <a:srgbClr val="0F172A"/>
                           </a:solidFill>
-                          <a:latin typeface="Inter"/>
+                          <a:latin typeface="Sora"/>
                         </a:rPr>
                         <a:t>2.3</a:t>
                       </a:r>
@@ -6478,7 +6480,7 @@
                           <a:solidFill>
                             <a:srgbClr val="0F172A"/>
                           </a:solidFill>
-                          <a:latin typeface="Inter"/>
+                          <a:latin typeface="Sora"/>
                         </a:rPr>
                         <a:t>Bottom quartile</a:t>
                       </a:r>
@@ -6500,7 +6502,7 @@
                           <a:solidFill>
                             <a:srgbClr val="0F172A"/>
                           </a:solidFill>
-                          <a:latin typeface="Inter"/>
+                          <a:latin typeface="Sora"/>
                         </a:rPr>
                         <a:t>17%</a:t>
                       </a:r>
@@ -6522,7 +6524,7 @@
                           <a:solidFill>
                             <a:srgbClr val="0F172A"/>
                           </a:solidFill>
-                          <a:latin typeface="Inter"/>
+                          <a:latin typeface="Sora"/>
                         </a:rPr>
                         <a:t>1.4</a:t>
                       </a:r>
@@ -6547,7 +6549,7 @@
         </p:nvSpPr>
         <p:spPr>
           <a:xfrm>
-            <a:off x="548640" y="3926677"/>
+            <a:off x="2666847" y="3926677"/>
             <a:ext cx="6858000" cy="201168"/>
           </a:xfrm>
           <a:prstGeom prst="rect">

</xml_diff>